<commit_message>
Three-speaker demo script, deck member slots
</commit_message>
<xml_diff>
--- a/docs/CollegeName_TeamName_Submission_ppt.pptx
+++ b/docs/CollegeName_TeamName_Submission_ppt.pptx
@@ -119,17 +119,17 @@
   <p:extLst>
     <p:ext uri="{521415D9-36F7-43E2-AB2F-B90AF26B5E84}">
       <p14:sectionLst xmlns:p14="http://schemas.microsoft.com/office/powerpoint/2010/main">
-        <p14:section name="Introduction" id="{3153db28-a837-1770-8209-5e7fe388d033}">
+        <p14:section name="Introduction" id="{54b3dab3-639d-b7ad-47f0-2f397af8b9a3}">
           <p14:sldIdLst>
             <p14:sldId id="256"/>
           </p14:sldIdLst>
         </p14:section>
-        <p14:section name="Problem" id="{d3b8df4f-cc6e-f052-2227-2a2c68e3a513}">
+        <p14:section name="Problem" id="{da8fd0f2-b447-728e-90ff-d56dbe6ca141}">
           <p14:sldIdLst>
             <p14:sldId id="257"/>
           </p14:sldIdLst>
         </p14:section>
-        <p14:section name="Solution" id="{95ba5540-e6a7-ce9a-6c33-09294db999c1}">
+        <p14:section name="Solution" id="{516ba368-8ba4-13c7-1fad-234877d33d88}">
           <p14:sldIdLst>
             <p14:sldId id="258"/>
             <p14:sldId id="259"/>
@@ -137,14 +137,14 @@
             <p14:sldId id="261"/>
           </p14:sldIdLst>
         </p14:section>
-        <p14:section name="Results" id="{f4922fc1-a6b8-f074-3c3a-6253c033957a}">
+        <p14:section name="Results" id="{26dfc396-f262-19fb-10ab-d9fc27209cc6}">
           <p14:sldIdLst>
             <p14:sldId id="262"/>
             <p14:sldId id="263"/>
             <p14:sldId id="264"/>
           </p14:sldIdLst>
         </p14:section>
-        <p14:section name="Wrap-up" id="{6790ad2d-47ba-5104-62c3-42ff38e82e8d}">
+        <p14:section name="Wrap-up" id="{cf53db81-852a-0e90-0a76-48dd66880f34}">
           <p14:sldIdLst>
             <p14:sldId id="265"/>
             <p14:sldId id="266"/>
@@ -3102,7 +3102,7 @@
                   <a:schemeClr val="bg2"/>
                 </a:solidFill>
               </a:rPr>
-              <a:t>&lt;CollegeName&gt;   ·   Members: &lt;Name 1&gt;, &lt;Name 2&gt;, &lt;Name 3&gt;, &lt;Name 4&gt;</a:t>
+              <a:t>&lt;CollegeName&gt;   ·   Members: &lt;Member 1&gt;, &lt;Member 2&gt;, &lt;Member 3&gt;</a:t>
             </a:r>
             <a:endParaRPr lang="en-US" sz="1600" dirty="0"/>
           </a:p>

</xml_diff>